<commit_message>
Checkpoint news scenarios, action guidance, and lean brief packets
</commit_message>
<xml_diff>
--- a/demo/templates/neoagent-v2-exec-review.pptx
+++ b/demo/templates/neoagent-v2-exec-review.pptx
@@ -1081,7 +1081,7 @@
           <a:lstStyle xmlns:a="http://schemas.openxmlformats.org/drawingml/2006/main"/>
           <a:p xmlns:a="http://schemas.openxmlformats.org/drawingml/2006/main">
             <a:r>
-              <a:t>The venue choice is a separate production decision. Do not invent cost or availability differences beyond the two offers. This deadline is not an additional goal of the executive meeting.</a:t>
+              <a:t>Priya has checked production requirements for both options and needs only a date preference. She handles booking and production arrangements. This reply deadline is not an additional goal of the executive meeting.</a:t>
             </a:r>
           </a:p>
         </p:txBody>
@@ -5543,7 +5543,7 @@
                 <a:ea typeface="Arial"/>
                 <a:cs typeface="Arial"/>
               </a:rPr>
-              <a:t>The venue choice determines the shoot date and crew booking. Dependent assets cannot be treated as scheduled until the replacement is confirmed.</a:t>
+              <a:t>Both shoot options work. Priya needs only the user's date preference, then handles booking. Assets remain unscheduled until booking is confirmed.</a:t>
             </a:r>
           </a:p>
           <a:p xmlns:a="http://schemas.openxmlformats.org/drawingml/2006/main">
@@ -5851,7 +5851,7 @@
                 <a:ea typeface="Arial"/>
                 <a:cs typeface="Arial"/>
               </a:rPr>
-              <a:t>Marketing shoot — decision required</a:t>
+              <a:t>Marketing shoot — preference needed</a:t>
             </a:r>
           </a:p>
         </p:txBody>
@@ -5931,7 +5931,7 @@
                 <a:ea typeface="Arial"/>
                 <a:cs typeface="Arial"/>
               </a:rPr>
-              <a:t>The planned venue is unavailable. Priya can hold Studio B on Friday or Studio C on Tuesday with the preferred crew until 4:30 PM today.</a:t>
+              <a:t>Priya checked both options. Studio B Friday and Studio C Tuesday both work. Reply with your preference by 4:30 PM today.</a:t>
             </a:r>
           </a:p>
           <a:p xmlns:a="http://schemas.openxmlformats.org/drawingml/2006/main">
@@ -5959,7 +5959,7 @@
                 <a:ea typeface="Arial"/>
                 <a:cs typeface="Arial"/>
               </a:rPr>
-              <a:t>TRADEOFF TO RESOLVE</a:t>
+              <a:t>YOUR PREFERENCE</a:t>
             </a:r>
           </a:p>
           <a:p xmlns:a="http://schemas.openxmlformats.org/drawingml/2006/main">
@@ -5982,7 +5982,7 @@
                 <a:ea typeface="Arial"/>
                 <a:cs typeface="Arial"/>
               </a:rPr>
-              <a:t>Choose the date that fits launch readiness and downstream production. Confirm availability before making new commitments to partners or the crew.</a:t>
+              <a:t>Priya has checked production requirements for both options. Only your Friday/Tuesday preference is needed.</a:t>
             </a:r>
           </a:p>
           <a:p xmlns:a="http://schemas.openxmlformats.org/drawingml/2006/main">
@@ -6033,7 +6033,7 @@
                 <a:ea typeface="Arial"/>
                 <a:cs typeface="Arial"/>
               </a:rPr>
-              <a:t>Once the date is chosen, Priya can confirm the venue and rebuild the production schedule. Missing the hold risks a campaign slip.</a:t>
+              <a:t>Priya will handle booking and production arrangements after your reply. The preference and booking remain unconfirmed.</a:t>
             </a:r>
           </a:p>
         </p:txBody>

</xml_diff>